<commit_message>
Update deck and Readme
</commit_message>
<xml_diff>
--- a/deliverables/htsr_model_zoo_deck/model_zoo_htsr_study.pptx
+++ b/deliverables/htsr_model_zoo_deck/model_zoo_htsr_study.pptx
@@ -26,9 +26,10 @@
     <p:sldId id="274" r:id="rId20"/>
     <p:sldId id="275" r:id="rId21"/>
     <p:sldId id="276" r:id="rId22"/>
+    <p:sldId id="277" r:id="rId23"/>
   </p:sldIdLst>
   <p:notesMasterIdLst>
-    <p:notesMasterId r:id="rId23"/>
+    <p:notesMasterId r:id="rId24"/>
   </p:notesMasterIdLst>
   <p:sldSz cx="12191695" cy="6858000"/>
   <p:notesSz cx="6858000" cy="12191695"/>
@@ -1708,6 +1709,94 @@
 </p:notes>
 </file>
 
+<file path=ppt/notesSlides/notesSlide22.xml><?xml version="1.0" encoding="utf-8"?>
+<p:notes xmlns:a="http://schemas.openxmlformats.org/drawingml/2006/main" xmlns:r="http://schemas.openxmlformats.org/officeDocument/2006/relationships" xmlns:p="http://schemas.openxmlformats.org/presentationml/2006/main">
+  <p:cSld>
+    <p:spTree>
+      <p:nvGrpSpPr>
+        <p:cNvPr id="1" name=""/>
+        <p:cNvGrpSpPr/>
+        <p:nvPr/>
+      </p:nvGrpSpPr>
+      <p:grpSpPr>
+        <a:xfrm>
+          <a:off x="0" y="0"/>
+          <a:ext cx="0" cy="0"/>
+          <a:chOff x="0" y="0"/>
+          <a:chExt cx="0" cy="0"/>
+        </a:xfrm>
+      </p:grpSpPr>
+      <p:sp>
+        <p:nvSpPr>
+          <p:cNvPr id="2" name="Slide Image Placeholder 1"/>
+          <p:cNvSpPr>
+            <a:spLocks noGrp="1" noRot="1" noChangeAspect="1"/>
+          </p:cNvSpPr>
+          <p:nvPr>
+            <p:ph type="sldImg"/>
+          </p:nvPr>
+        </p:nvSpPr>
+        <p:spPr/>
+      </p:sp>
+      <p:sp>
+        <p:nvSpPr>
+          <p:cNvPr id="3" name="Notes Placeholder 2"/>
+          <p:cNvSpPr>
+            <a:spLocks noGrp="1"/>
+          </p:cNvSpPr>
+          <p:nvPr>
+            <p:ph type="body" idx="1"/>
+          </p:nvPr>
+        </p:nvSpPr>
+        <p:spPr/>
+        <p:txBody>
+          <a:bodyPr/>
+          <a:lstStyle/>
+          <a:p>
+            <a:r>
+              <a:rPr lang="en-US" dirty="0"/>
+              <a:t/>
+            </a:r>
+            <a:endParaRPr lang="en-US" dirty="0"/>
+          </a:p>
+        </p:txBody>
+      </p:sp>
+      <p:sp>
+        <p:nvSpPr>
+          <p:cNvPr id="4" name="Slide Number Placeholder 3"/>
+          <p:cNvSpPr>
+            <a:spLocks noGrp="1"/>
+          </p:cNvSpPr>
+          <p:nvPr>
+            <p:ph type="sldNum" sz="quarter" idx="10"/>
+          </p:nvPr>
+        </p:nvSpPr>
+        <p:spPr/>
+        <p:txBody>
+          <a:bodyPr/>
+          <a:lstStyle/>
+          <a:p>
+            <a:fld id="{F7021451-1387-4CA6-816F-3879F97B5CBC}" type="slidenum">
+              <a:rPr lang="en-US"/>
+              <a:t>22</a:t>
+            </a:fld>
+            <a:endParaRPr lang="en-US"/>
+          </a:p>
+        </p:txBody>
+      </p:sp>
+    </p:spTree>
+    <p:extLst>
+      <p:ext uri="{BB962C8B-B14F-4D97-AF65-F5344CB8AC3E}">
+        <p14:creationId xmlns:p14="http://schemas.microsoft.com/office/powerpoint/2010/main" val="1024086991"/>
+      </p:ext>
+    </p:extLst>
+  </p:cSld>
+  <p:clrMapOvr>
+    <a:masterClrMapping/>
+  </p:clrMapOvr>
+</p:notes>
+</file>
+
 <file path=ppt/notesSlides/notesSlide3.xml><?xml version="1.0" encoding="utf-8"?>
 <p:notes xmlns:a="http://schemas.openxmlformats.org/drawingml/2006/main" xmlns:r="http://schemas.openxmlformats.org/officeDocument/2006/relationships" xmlns:p="http://schemas.openxmlformats.org/presentationml/2006/main">
   <p:cSld>
@@ -6388,6 +6477,45 @@
         </p:nvSpPr>
         <p:spPr>
           <a:xfrm>
+            <a:off x="685800" y="5925312"/>
+            <a:ext cx="6766560" cy="219456"/>
+          </a:xfrm>
+          <a:prstGeom prst="rect">
+            <a:avLst/>
+          </a:prstGeom>
+          <a:noFill/>
+          <a:ln/>
+        </p:spPr>
+        <p:txBody>
+          <a:bodyPr wrap="square" lIns="0" tIns="0" rIns="0" bIns="0" rtlCol="0" anchor="t"/>
+          <a:lstStyle/>
+          <a:p>
+            <a:pPr indent="0" marL="0">
+              <a:buNone/>
+            </a:pPr>
+            <a:r>
+              <a:rPr lang="en-US" sz="1000" dirty="0">
+                <a:solidFill>
+                  <a:srgbClr val="D9E2EC"/>
+                </a:solidFill>
+                <a:latin typeface="Aptos" pitchFamily="34" charset="0"/>
+                <a:ea typeface="Aptos" pitchFamily="34" charset="-122"/>
+                <a:cs typeface="Aptos" pitchFamily="34" charset="-120"/>
+              </a:rPr>
+              <a:t>September 2026 results / October 2026 scale-up plan</a:t>
+            </a:r>
+            <a:endParaRPr lang="en-US" sz="1000" dirty="0"/>
+          </a:p>
+        </p:txBody>
+      </p:sp>
+      <p:sp>
+        <p:nvSpPr>
+          <p:cNvPr id="134" name="Text 132"/>
+          <p:cNvSpPr/>
+          <p:nvPr/>
+        </p:nvSpPr>
+        <p:spPr>
+          <a:xfrm>
             <a:off x="685800" y="6336792"/>
             <a:ext cx="6766560" cy="164592"/>
           </a:xfrm>
@@ -12716,7 +12844,7 @@
                 <a:ea typeface="Aptos" pitchFamily="34" charset="-122"/>
                 <a:cs typeface="Aptos" pitchFamily="34" charset="-120"/>
               </a:rPr>
-              <a:t>Exploratory evidence, not an untouched replication. Before deployment: verify checkpoint revisions, test external roots, and calibrate rejection on separate data.</a:t>
+              <a:t>Next experiment: use the newer pinned collection to test whether weight measurements improve task-specific model choices. See the October scale-up plan in the appendix.</a:t>
             </a:r>
             <a:endParaRPr lang="en-US" sz="1120" dirty="0"/>
           </a:p>
@@ -12907,7 +13035,7 @@
                 <a:ea typeface="Aptos Display" pitchFamily="34" charset="-122"/>
                 <a:cs typeface="Aptos Display" pitchFamily="34" charset="-120"/>
               </a:rPr>
-              <a:t>Methods and definitions</a:t>
+              <a:t>Methods and next study</a:t>
             </a:r>
             <a:endParaRPr lang="en-US" sz="3800" dirty="0"/>
           </a:p>
@@ -13359,6 +13487,107 @@
       <p:sp>
         <p:nvSpPr>
           <p:cNvPr id="20" name="Text 18"/>
+          <p:cNvSpPr/>
+          <p:nvPr/>
+        </p:nvSpPr>
+        <p:spPr>
+          <a:xfrm>
+            <a:off x="713232" y="5696712"/>
+            <a:ext cx="502920" cy="274320"/>
+          </a:xfrm>
+          <a:prstGeom prst="rect">
+            <a:avLst/>
+          </a:prstGeom>
+          <a:noFill/>
+          <a:ln/>
+        </p:spPr>
+        <p:txBody>
+          <a:bodyPr wrap="square" lIns="0" tIns="0" rIns="0" bIns="0" rtlCol="0" anchor="ctr"/>
+          <a:lstStyle/>
+          <a:p>
+            <a:pPr indent="0" marL="0">
+              <a:buNone/>
+            </a:pPr>
+            <a:r>
+              <a:rPr lang="en-US" sz="1050" b="1" dirty="0">
+                <a:solidFill>
+                  <a:srgbClr val="FDB515"/>
+                </a:solidFill>
+                <a:latin typeface="Aptos" pitchFamily="34" charset="0"/>
+                <a:ea typeface="Aptos" pitchFamily="34" charset="-122"/>
+                <a:cs typeface="Aptos" pitchFamily="34" charset="-120"/>
+              </a:rPr>
+              <a:t>A5</a:t>
+            </a:r>
+            <a:endParaRPr lang="en-US" sz="1050" dirty="0"/>
+          </a:p>
+        </p:txBody>
+      </p:sp>
+      <p:sp>
+        <p:nvSpPr>
+          <p:cNvPr id="21" name="Shape 19"/>
+          <p:cNvSpPr/>
+          <p:nvPr/>
+        </p:nvSpPr>
+        <p:spPr>
+          <a:xfrm>
+            <a:off x="1353312" y="5833872"/>
+            <a:ext cx="603504" cy="0"/>
+          </a:xfrm>
+          <a:prstGeom prst="line">
+            <a:avLst/>
+          </a:prstGeom>
+          <a:noFill/>
+          <a:ln w="22860">
+            <a:solidFill>
+              <a:srgbClr val="FDB515"/>
+            </a:solidFill>
+            <a:prstDash val="solid"/>
+          </a:ln>
+        </p:spPr>
+      </p:sp>
+      <p:sp>
+        <p:nvSpPr>
+          <p:cNvPr id="22" name="Text 20"/>
+          <p:cNvSpPr/>
+          <p:nvPr/>
+        </p:nvSpPr>
+        <p:spPr>
+          <a:xfrm>
+            <a:off x="2139696" y="5687568"/>
+            <a:ext cx="3840480" cy="310896"/>
+          </a:xfrm>
+          <a:prstGeom prst="rect">
+            <a:avLst/>
+          </a:prstGeom>
+          <a:noFill/>
+          <a:ln/>
+        </p:spPr>
+        <p:txBody>
+          <a:bodyPr wrap="square" lIns="0" tIns="0" rIns="0" bIns="0" rtlCol="0" anchor="ctr"/>
+          <a:lstStyle/>
+          <a:p>
+            <a:pPr indent="0" marL="0">
+              <a:buNone/>
+            </a:pPr>
+            <a:r>
+              <a:rPr lang="en-US" sz="1400" b="1" dirty="0">
+                <a:solidFill>
+                  <a:srgbClr val="FFFFFF"/>
+                </a:solidFill>
+                <a:latin typeface="Aptos" pitchFamily="34" charset="0"/>
+                <a:ea typeface="Aptos" pitchFamily="34" charset="-122"/>
+                <a:cs typeface="Aptos" pitchFamily="34" charset="-120"/>
+              </a:rPr>
+              <a:t>October scale-up research plan</a:t>
+            </a:r>
+            <a:endParaRPr lang="en-US" sz="1400" dirty="0"/>
+          </a:p>
+        </p:txBody>
+      </p:sp>
+      <p:sp>
+        <p:nvSpPr>
+          <p:cNvPr id="23" name="Text 21"/>
           <p:cNvSpPr/>
           <p:nvPr/>
         </p:nvSpPr>
@@ -13665,7 +13894,7 @@
                 <a:ea typeface="Aptos" pitchFamily="34" charset="-122"/>
                 <a:cs typeface="Aptos" pitchFamily="34" charset="-120"/>
               </a:rPr>
-              <a:t>Sources: Model-Zoo/esd_experiment/gputracker and Model-Zoo/docs/operations/analysis.md</a:t>
+              <a:t>Historical collection workflow; newer operational collector: /jumbo/yaoqingyang/kinshuk/Model-Zoo/docs/operations/analysis.md</a:t>
             </a:r>
             <a:endParaRPr lang="en-US" sz="660" dirty="0"/>
           </a:p>
@@ -15203,7 +15432,7 @@
                 <a:ea typeface="Aptos" pitchFamily="34" charset="-122"/>
                 <a:cs typeface="Aptos" pitchFamily="34" charset="-120"/>
               </a:rPr>
-              <a:t>Sources: Model-Zoo/esd_experiment/src/worker.py and Model-Zoo/README.md</a:t>
+              <a:t>Sources: historical model statistics; current collector: /jumbo/yaoqingyang/kinshuk/Model-Zoo/docs/operations/analysis.md</a:t>
             </a:r>
             <a:endParaRPr lang="en-US" sz="660" dirty="0"/>
           </a:p>
@@ -16085,7 +16314,7 @@
                 <a:ea typeface="Aptos" pitchFamily="34" charset="-122"/>
                 <a:cs typeface="Aptos" pitchFamily="34" charset="-120"/>
               </a:rPr>
-              <a:t>Optional eigenvalues</a:t>
+              <a:t>Full spectra</a:t>
             </a:r>
             <a:endParaRPr lang="en-US" sz="930" dirty="0"/>
           </a:p>
@@ -16102,7 +16331,7 @@
                 <a:ea typeface="Aptos" pitchFamily="34" charset="-122"/>
                 <a:cs typeface="Aptos" pitchFamily="34" charset="-120"/>
               </a:rPr>
-              <a:t>larger files; useful for later re-fitting</a:t>
+              <a:t>current collector: saved by default; opt-out available</a:t>
             </a:r>
             <a:endParaRPr lang="en-US" sz="930" dirty="0"/>
           </a:p>
@@ -16260,7 +16489,7 @@
                 <a:ea typeface="Aptos" pitchFamily="34" charset="-122"/>
                 <a:cs typeface="Aptos" pitchFamily="34" charset="-120"/>
               </a:rPr>
-              <a:t>Analysis continues past inaccessible or repeatedly failing models after the configured retry limit. Completed records remain available for aggregation.</a:t>
+              <a:t>New collector: pinned revisions and matrix coverage. Historical results here still use stored DKS alpha; the new default uses the fixed-tail rule.</a:t>
             </a:r>
             <a:endParaRPr lang="en-US" sz="1030" dirty="0"/>
           </a:p>
@@ -19446,6 +19675,1406 @@
 </p:sld>
 </file>
 
+<file path=ppt/slides/slide22.xml><?xml version="1.0" encoding="utf-8"?>
+<p:sld xmlns:a="http://schemas.openxmlformats.org/drawingml/2006/main" xmlns:r="http://schemas.openxmlformats.org/officeDocument/2006/relationships" xmlns:p="http://schemas.openxmlformats.org/presentationml/2006/main">
+  <p:cSld name="Slide 22">
+    <p:bg>
+      <p:bgPr>
+        <a:solidFill>
+          <a:srgbClr val="FFFFFF"/>
+        </a:solidFill>
+      </p:bgPr>
+    </p:bg>
+    <p:spTree>
+      <p:nvGrpSpPr>
+        <p:cNvPr id="1" name=""/>
+        <p:cNvGrpSpPr/>
+        <p:nvPr/>
+      </p:nvGrpSpPr>
+      <p:grpSpPr>
+        <a:xfrm>
+          <a:off x="0" y="0"/>
+          <a:ext cx="0" cy="0"/>
+          <a:chOff x="0" y="0"/>
+          <a:chExt cx="0" cy="0"/>
+        </a:xfrm>
+      </p:grpSpPr>
+      <p:sp>
+        <p:nvSpPr>
+          <p:cNvPr id="2" name="Shape 0"/>
+          <p:cNvSpPr/>
+          <p:nvPr/>
+        </p:nvSpPr>
+        <p:spPr>
+          <a:xfrm>
+            <a:off x="0" y="0"/>
+            <a:ext cx="5715000" cy="50292"/>
+          </a:xfrm>
+          <a:prstGeom prst="rect">
+            <a:avLst/>
+          </a:prstGeom>
+          <a:solidFill>
+            <a:srgbClr val="002676"/>
+          </a:solidFill>
+          <a:ln w="12700">
+            <a:solidFill>
+              <a:srgbClr val="333333">
+                <a:alpha val="0"/>
+              </a:srgbClr>
+            </a:solidFill>
+            <a:prstDash val="solid"/>
+          </a:ln>
+        </p:spPr>
+      </p:sp>
+      <p:sp>
+        <p:nvSpPr>
+          <p:cNvPr id="3" name="Shape 1"/>
+          <p:cNvSpPr/>
+          <p:nvPr/>
+        </p:nvSpPr>
+        <p:spPr>
+          <a:xfrm>
+            <a:off x="5715000" y="0"/>
+            <a:ext cx="3337560" cy="50292"/>
+          </a:xfrm>
+          <a:prstGeom prst="rect">
+            <a:avLst/>
+          </a:prstGeom>
+          <a:solidFill>
+            <a:srgbClr val="00693E"/>
+          </a:solidFill>
+          <a:ln w="12700">
+            <a:solidFill>
+              <a:srgbClr val="333333">
+                <a:alpha val="0"/>
+              </a:srgbClr>
+            </a:solidFill>
+            <a:prstDash val="solid"/>
+          </a:ln>
+        </p:spPr>
+      </p:sp>
+      <p:sp>
+        <p:nvSpPr>
+          <p:cNvPr id="4" name="Shape 2"/>
+          <p:cNvSpPr/>
+          <p:nvPr/>
+        </p:nvSpPr>
+        <p:spPr>
+          <a:xfrm>
+            <a:off x="9052560" y="0"/>
+            <a:ext cx="3139135" cy="50292"/>
+          </a:xfrm>
+          <a:prstGeom prst="rect">
+            <a:avLst/>
+          </a:prstGeom>
+          <a:solidFill>
+            <a:srgbClr val="FDB515"/>
+          </a:solidFill>
+          <a:ln w="12700">
+            <a:solidFill>
+              <a:srgbClr val="333333">
+                <a:alpha val="0"/>
+              </a:srgbClr>
+            </a:solidFill>
+            <a:prstDash val="solid"/>
+          </a:ln>
+        </p:spPr>
+      </p:sp>
+      <p:sp>
+        <p:nvSpPr>
+          <p:cNvPr id="5" name="Text 3"/>
+          <p:cNvSpPr/>
+          <p:nvPr/>
+        </p:nvSpPr>
+        <p:spPr>
+          <a:xfrm>
+            <a:off x="530352" y="201168"/>
+            <a:ext cx="4937760" cy="201168"/>
+          </a:xfrm>
+          <a:prstGeom prst="rect">
+            <a:avLst/>
+          </a:prstGeom>
+          <a:noFill/>
+          <a:ln/>
+        </p:spPr>
+        <p:txBody>
+          <a:bodyPr wrap="square" lIns="0" tIns="0" rIns="0" bIns="0" rtlCol="0" anchor="t"/>
+          <a:lstStyle/>
+          <a:p>
+            <a:pPr indent="0" marL="0">
+              <a:buNone/>
+            </a:pPr>
+            <a:r>
+              <a:rPr lang="en-US" sz="900" b="1" dirty="0">
+                <a:solidFill>
+                  <a:srgbClr val="00693E"/>
+                </a:solidFill>
+                <a:latin typeface="Aptos" pitchFamily="34" charset="0"/>
+                <a:ea typeface="Aptos" pitchFamily="34" charset="-122"/>
+                <a:cs typeface="Aptos" pitchFamily="34" charset="-120"/>
+              </a:rPr>
+              <a:t>APPENDIX A5 · OCTOBER RESEARCH PLAN</a:t>
+            </a:r>
+            <a:endParaRPr lang="en-US" sz="900" dirty="0"/>
+          </a:p>
+        </p:txBody>
+      </p:sp>
+      <p:sp>
+        <p:nvSpPr>
+          <p:cNvPr id="6" name="Text 4"/>
+          <p:cNvSpPr/>
+          <p:nvPr/>
+        </p:nvSpPr>
+        <p:spPr>
+          <a:xfrm>
+            <a:off x="530352" y="448056"/>
+            <a:ext cx="11109960" cy="420624"/>
+          </a:xfrm>
+          <a:prstGeom prst="rect">
+            <a:avLst/>
+          </a:prstGeom>
+          <a:noFill/>
+          <a:ln/>
+        </p:spPr>
+        <p:txBody>
+          <a:bodyPr wrap="square" lIns="0" tIns="0" rIns="0" bIns="0" rtlCol="0" anchor="ctr"/>
+          <a:lstStyle/>
+          <a:p>
+            <a:pPr indent="0" marL="0">
+              <a:buNone/>
+            </a:pPr>
+            <a:r>
+              <a:rPr lang="en-US" sz="2500" b="1" dirty="0">
+                <a:solidFill>
+                  <a:srgbClr val="14213D"/>
+                </a:solidFill>
+                <a:latin typeface="Aptos Display" pitchFamily="34" charset="0"/>
+                <a:ea typeface="Aptos Display" pitchFamily="34" charset="-122"/>
+                <a:cs typeface="Aptos Display" pitchFamily="34" charset="-120"/>
+              </a:rPr>
+              <a:t>Do weight measurements improve model selection for a task?</a:t>
+            </a:r>
+            <a:endParaRPr lang="en-US" sz="2500" dirty="0"/>
+          </a:p>
+        </p:txBody>
+      </p:sp>
+      <p:sp>
+        <p:nvSpPr>
+          <p:cNvPr id="7" name="Shape 5"/>
+          <p:cNvSpPr/>
+          <p:nvPr/>
+        </p:nvSpPr>
+        <p:spPr>
+          <a:xfrm>
+            <a:off x="530352" y="969264"/>
+            <a:ext cx="11109960" cy="0"/>
+          </a:xfrm>
+          <a:prstGeom prst="line">
+            <a:avLst/>
+          </a:prstGeom>
+          <a:noFill/>
+          <a:ln w="10160">
+            <a:solidFill>
+              <a:srgbClr val="D9E2EC"/>
+            </a:solidFill>
+            <a:prstDash val="solid"/>
+          </a:ln>
+        </p:spPr>
+      </p:sp>
+      <p:sp>
+        <p:nvSpPr>
+          <p:cNvPr id="8" name="Shape 6"/>
+          <p:cNvSpPr/>
+          <p:nvPr/>
+        </p:nvSpPr>
+        <p:spPr>
+          <a:xfrm>
+            <a:off x="530352" y="6556248"/>
+            <a:ext cx="11109960" cy="0"/>
+          </a:xfrm>
+          <a:prstGeom prst="line">
+            <a:avLst/>
+          </a:prstGeom>
+          <a:noFill/>
+          <a:ln w="8890">
+            <a:solidFill>
+              <a:srgbClr val="D9E2EC"/>
+            </a:solidFill>
+            <a:prstDash val="solid"/>
+          </a:ln>
+        </p:spPr>
+      </p:sp>
+      <p:sp>
+        <p:nvSpPr>
+          <p:cNvPr id="9" name="Text 7"/>
+          <p:cNvSpPr/>
+          <p:nvPr/>
+        </p:nvSpPr>
+        <p:spPr>
+          <a:xfrm>
+            <a:off x="530352" y="6620256"/>
+            <a:ext cx="9966960" cy="118872"/>
+          </a:xfrm>
+          <a:prstGeom prst="rect">
+            <a:avLst/>
+          </a:prstGeom>
+          <a:noFill/>
+          <a:ln/>
+        </p:spPr>
+        <p:txBody>
+          <a:bodyPr wrap="square" lIns="0" tIns="0" rIns="0" bIns="0" rtlCol="0" anchor="ctr"/>
+          <a:lstStyle/>
+          <a:p>
+            <a:pPr indent="0" marL="0">
+              <a:buNone/>
+            </a:pPr>
+            <a:r>
+              <a:rPr lang="en-US" sz="660" dirty="0">
+                <a:solidFill>
+                  <a:srgbClr val="667085"/>
+                </a:solidFill>
+                <a:latin typeface="Aptos" pitchFamily="34" charset="0"/>
+                <a:ea typeface="Aptos" pitchFamily="34" charset="-122"/>
+                <a:cs typeface="Aptos" pitchFamily="34" charset="-120"/>
+              </a:rPr>
+              <a:t>Source: docs/research/scaleup/model_zoo_frontier_research_plan_2026-10-23.md; proposed experiments and milestones.</a:t>
+            </a:r>
+            <a:endParaRPr lang="en-US" sz="660" dirty="0"/>
+          </a:p>
+        </p:txBody>
+      </p:sp>
+      <p:sp>
+        <p:nvSpPr>
+          <p:cNvPr id="10" name="Text 8"/>
+          <p:cNvSpPr/>
+          <p:nvPr/>
+        </p:nvSpPr>
+        <p:spPr>
+          <a:xfrm>
+            <a:off x="11045952" y="6601968"/>
+            <a:ext cx="585216" cy="137160"/>
+          </a:xfrm>
+          <a:prstGeom prst="rect">
+            <a:avLst/>
+          </a:prstGeom>
+          <a:noFill/>
+          <a:ln/>
+        </p:spPr>
+        <p:txBody>
+          <a:bodyPr wrap="square" lIns="0" tIns="0" rIns="0" bIns="0" rtlCol="0" anchor="ctr"/>
+          <a:lstStyle/>
+          <a:p>
+            <a:pPr algn="r" indent="0" marL="0">
+              <a:buNone/>
+            </a:pPr>
+            <a:r>
+              <a:rPr lang="en-US" sz="800" b="1" dirty="0">
+                <a:solidFill>
+                  <a:srgbClr val="00693E"/>
+                </a:solidFill>
+                <a:latin typeface="Aptos" pitchFamily="34" charset="0"/>
+                <a:ea typeface="Aptos" pitchFamily="34" charset="-122"/>
+                <a:cs typeface="Aptos" pitchFamily="34" charset="-120"/>
+              </a:rPr>
+              <a:t>22</a:t>
+            </a:r>
+            <a:endParaRPr lang="en-US" sz="800" dirty="0"/>
+          </a:p>
+        </p:txBody>
+      </p:sp>
+      <p:sp>
+        <p:nvSpPr>
+          <p:cNvPr id="11" name="Text 9"/>
+          <p:cNvSpPr/>
+          <p:nvPr/>
+        </p:nvSpPr>
+        <p:spPr>
+          <a:xfrm>
+            <a:off x="621792" y="1143000"/>
+            <a:ext cx="10954512" cy="292608"/>
+          </a:xfrm>
+          <a:prstGeom prst="rect">
+            <a:avLst/>
+          </a:prstGeom>
+          <a:noFill/>
+          <a:ln/>
+        </p:spPr>
+        <p:txBody>
+          <a:bodyPr wrap="square" lIns="0" tIns="0" rIns="0" bIns="0" rtlCol="0" anchor="t"/>
+          <a:lstStyle/>
+          <a:p>
+            <a:pPr indent="0" marL="0">
+              <a:buNone/>
+            </a:pPr>
+            <a:r>
+              <a:rPr lang="en-US" sz="1200" dirty="0">
+                <a:solidFill>
+                  <a:srgbClr val="344054"/>
+                </a:solidFill>
+                <a:latin typeface="Aptos" pitchFamily="34" charset="0"/>
+                <a:ea typeface="Aptos" pitchFamily="34" charset="-122"/>
+                <a:cs typeface="Aptos" pitchFamily="34" charset="-120"/>
+              </a:rPr>
+              <a:t>Measure score lost versus the best feasible model, evaluation cost, and constraint failures.</a:t>
+            </a:r>
+            <a:endParaRPr lang="en-US" sz="1200" dirty="0"/>
+          </a:p>
+        </p:txBody>
+      </p:sp>
+      <p:sp>
+        <p:nvSpPr>
+          <p:cNvPr id="12" name="Text 10"/>
+          <p:cNvSpPr/>
+          <p:nvPr/>
+        </p:nvSpPr>
+        <p:spPr>
+          <a:xfrm>
+            <a:off x="621792" y="1773936"/>
+            <a:ext cx="2240280" cy="603504"/>
+          </a:xfrm>
+          <a:prstGeom prst="roundRect">
+            <a:avLst>
+              <a:gd name="adj" fmla="val 7576"/>
+            </a:avLst>
+          </a:prstGeom>
+          <a:solidFill>
+            <a:srgbClr val="EAF2FF"/>
+          </a:solidFill>
+          <a:ln w="10160">
+            <a:solidFill>
+              <a:srgbClr val="003B95"/>
+            </a:solidFill>
+          </a:ln>
+        </p:spPr>
+        <p:txBody>
+          <a:bodyPr wrap="square" lIns="1778" tIns="1778" rIns="1778" bIns="1778" rtlCol="0" anchor="ctr"/>
+          <a:lstStyle/>
+          <a:p>
+            <a:pPr algn="ctr" indent="0" marL="0">
+              <a:buNone/>
+            </a:pPr>
+            <a:r>
+              <a:rPr lang="en-US" sz="1250" b="1" dirty="0">
+                <a:solidFill>
+                  <a:srgbClr val="14213D"/>
+                </a:solidFill>
+                <a:latin typeface="Aptos" pitchFamily="34" charset="0"/>
+                <a:ea typeface="Aptos" pitchFamily="34" charset="-122"/>
+                <a:cs typeface="Aptos" pitchFamily="34" charset="-120"/>
+              </a:rPr>
+              <a:t>Task + constraints</a:t>
+            </a:r>
+            <a:endParaRPr lang="en-US" sz="1250" dirty="0"/>
+          </a:p>
+        </p:txBody>
+      </p:sp>
+      <p:sp>
+        <p:nvSpPr>
+          <p:cNvPr id="13" name="Text 11"/>
+          <p:cNvSpPr/>
+          <p:nvPr/>
+        </p:nvSpPr>
+        <p:spPr>
+          <a:xfrm>
+            <a:off x="621792" y="2532888"/>
+            <a:ext cx="2240280" cy="420624"/>
+          </a:xfrm>
+          <a:prstGeom prst="rect">
+            <a:avLst/>
+          </a:prstGeom>
+          <a:noFill/>
+          <a:ln/>
+        </p:spPr>
+        <p:txBody>
+          <a:bodyPr wrap="square" lIns="0" tIns="0" rIns="0" bIns="0" rtlCol="0" anchor="t"/>
+          <a:lstStyle/>
+          <a:p>
+            <a:pPr algn="ctr" indent="0" marL="0">
+              <a:buNone/>
+            </a:pPr>
+            <a:r>
+              <a:rPr lang="en-US" sz="1050" dirty="0">
+                <a:solidFill>
+                  <a:srgbClr val="344054"/>
+                </a:solidFill>
+                <a:latin typeface="Aptos" pitchFamily="34" charset="0"/>
+                <a:ea typeface="Aptos" pitchFamily="34" charset="-122"/>
+                <a:cs typeface="Aptos" pitchFamily="34" charset="-120"/>
+              </a:rPr>
+              <a:t>examples, memory, latency</a:t>
+            </a:r>
+            <a:endParaRPr lang="en-US" sz="1050" dirty="0"/>
+          </a:p>
+        </p:txBody>
+      </p:sp>
+      <p:sp>
+        <p:nvSpPr>
+          <p:cNvPr id="14" name="Shape 12"/>
+          <p:cNvSpPr/>
+          <p:nvPr/>
+        </p:nvSpPr>
+        <p:spPr>
+          <a:xfrm>
+            <a:off x="2980944" y="2075688"/>
+            <a:ext cx="393192" cy="0"/>
+          </a:xfrm>
+          <a:prstGeom prst="line">
+            <a:avLst/>
+          </a:prstGeom>
+          <a:noFill/>
+          <a:ln w="19050">
+            <a:solidFill>
+              <a:srgbClr val="003B95"/>
+            </a:solidFill>
+            <a:prstDash val="solid"/>
+            <a:tailEnd type="triangle"/>
+          </a:ln>
+        </p:spPr>
+      </p:sp>
+      <p:sp>
+        <p:nvSpPr>
+          <p:cNvPr id="15" name="Text 13"/>
+          <p:cNvSpPr/>
+          <p:nvPr/>
+        </p:nvSpPr>
+        <p:spPr>
+          <a:xfrm>
+            <a:off x="3511296" y="1773936"/>
+            <a:ext cx="2240280" cy="603504"/>
+          </a:xfrm>
+          <a:prstGeom prst="roundRect">
+            <a:avLst>
+              <a:gd name="adj" fmla="val 7576"/>
+            </a:avLst>
+          </a:prstGeom>
+          <a:solidFill>
+            <a:srgbClr val="E4F3EA"/>
+          </a:solidFill>
+          <a:ln w="10160">
+            <a:solidFill>
+              <a:srgbClr val="00693E"/>
+            </a:solidFill>
+          </a:ln>
+        </p:spPr>
+        <p:txBody>
+          <a:bodyPr wrap="square" lIns="1778" tIns="1778" rIns="1778" bIns="1778" rtlCol="0" anchor="ctr"/>
+          <a:lstStyle/>
+          <a:p>
+            <a:pPr algn="ctr" indent="0" marL="0">
+              <a:buNone/>
+            </a:pPr>
+            <a:r>
+              <a:rPr lang="en-US" sz="1250" b="1" dirty="0">
+                <a:solidFill>
+                  <a:srgbClr val="14213D"/>
+                </a:solidFill>
+                <a:latin typeface="Aptos" pitchFamily="34" charset="0"/>
+                <a:ea typeface="Aptos" pitchFamily="34" charset="-122"/>
+                <a:cs typeface="Aptos" pitchFamily="34" charset="-120"/>
+              </a:rPr>
+              <a:t>Retrieve candidates</a:t>
+            </a:r>
+            <a:endParaRPr lang="en-US" sz="1250" dirty="0"/>
+          </a:p>
+        </p:txBody>
+      </p:sp>
+      <p:sp>
+        <p:nvSpPr>
+          <p:cNvPr id="16" name="Text 14"/>
+          <p:cNvSpPr/>
+          <p:nvPr/>
+        </p:nvSpPr>
+        <p:spPr>
+          <a:xfrm>
+            <a:off x="3511296" y="2532888"/>
+            <a:ext cx="2240280" cy="420624"/>
+          </a:xfrm>
+          <a:prstGeom prst="rect">
+            <a:avLst/>
+          </a:prstGeom>
+          <a:noFill/>
+          <a:ln/>
+        </p:spPr>
+        <p:txBody>
+          <a:bodyPr wrap="square" lIns="0" tIns="0" rIns="0" bIns="0" rtlCol="0" anchor="t"/>
+          <a:lstStyle/>
+          <a:p>
+            <a:pPr algn="ctr" indent="0" marL="0">
+              <a:buNone/>
+            </a:pPr>
+            <a:r>
+              <a:rPr lang="en-US" sz="1050" dirty="0">
+                <a:solidFill>
+                  <a:srgbClr val="344054"/>
+                </a:solidFill>
+                <a:latin typeface="Aptos" pitchFamily="34" charset="0"/>
+                <a:ea typeface="Aptos" pitchFamily="34" charset="-122"/>
+                <a:cs typeface="Aptos" pitchFamily="34" charset="-120"/>
+              </a:rPr>
+              <a:t>use model groups and evidence</a:t>
+            </a:r>
+            <a:endParaRPr lang="en-US" sz="1050" dirty="0"/>
+          </a:p>
+        </p:txBody>
+      </p:sp>
+      <p:sp>
+        <p:nvSpPr>
+          <p:cNvPr id="17" name="Shape 15"/>
+          <p:cNvSpPr/>
+          <p:nvPr/>
+        </p:nvSpPr>
+        <p:spPr>
+          <a:xfrm>
+            <a:off x="5870448" y="2075688"/>
+            <a:ext cx="393192" cy="0"/>
+          </a:xfrm>
+          <a:prstGeom prst="line">
+            <a:avLst/>
+          </a:prstGeom>
+          <a:noFill/>
+          <a:ln w="19050">
+            <a:solidFill>
+              <a:srgbClr val="00693E"/>
+            </a:solidFill>
+            <a:prstDash val="solid"/>
+            <a:tailEnd type="triangle"/>
+          </a:ln>
+        </p:spPr>
+      </p:sp>
+      <p:sp>
+        <p:nvSpPr>
+          <p:cNvPr id="18" name="Text 16"/>
+          <p:cNvSpPr/>
+          <p:nvPr/>
+        </p:nvSpPr>
+        <p:spPr>
+          <a:xfrm>
+            <a:off x="6400800" y="1773936"/>
+            <a:ext cx="2240280" cy="603504"/>
+          </a:xfrm>
+          <a:prstGeom prst="roundRect">
+            <a:avLst>
+              <a:gd name="adj" fmla="val 7576"/>
+            </a:avLst>
+          </a:prstGeom>
+          <a:solidFill>
+            <a:srgbClr val="EAF2FF"/>
+          </a:solidFill>
+          <a:ln w="10160">
+            <a:solidFill>
+              <a:srgbClr val="003B95"/>
+            </a:solidFill>
+          </a:ln>
+        </p:spPr>
+        <p:txBody>
+          <a:bodyPr wrap="square" lIns="1778" tIns="1778" rIns="1778" bIns="1778" rtlCol="0" anchor="ctr"/>
+          <a:lstStyle/>
+          <a:p>
+            <a:pPr algn="ctr" indent="0" marL="0">
+              <a:buNone/>
+            </a:pPr>
+            <a:r>
+              <a:rPr lang="en-US" sz="1250" b="1" dirty="0">
+                <a:solidFill>
+                  <a:srgbClr val="14213D"/>
+                </a:solidFill>
+                <a:latin typeface="Aptos" pitchFamily="34" charset="0"/>
+                <a:ea typeface="Aptos" pitchFamily="34" charset="-122"/>
+                <a:cs typeface="Aptos" pitchFamily="34" charset="-120"/>
+              </a:rPr>
+              <a:t>Estimate suitability</a:t>
+            </a:r>
+            <a:endParaRPr lang="en-US" sz="1250" dirty="0"/>
+          </a:p>
+        </p:txBody>
+      </p:sp>
+      <p:sp>
+        <p:nvSpPr>
+          <p:cNvPr id="19" name="Text 17"/>
+          <p:cNvSpPr/>
+          <p:nvPr/>
+        </p:nvSpPr>
+        <p:spPr>
+          <a:xfrm>
+            <a:off x="6400800" y="2532888"/>
+            <a:ext cx="2240280" cy="420624"/>
+          </a:xfrm>
+          <a:prstGeom prst="rect">
+            <a:avLst/>
+          </a:prstGeom>
+          <a:noFill/>
+          <a:ln/>
+        </p:spPr>
+        <p:txBody>
+          <a:bodyPr wrap="square" lIns="0" tIns="0" rIns="0" bIns="0" rtlCol="0" anchor="t"/>
+          <a:lstStyle/>
+          <a:p>
+            <a:pPr algn="ctr" indent="0" marL="0">
+              <a:buNone/>
+            </a:pPr>
+            <a:r>
+              <a:rPr lang="en-US" sz="1050" dirty="0">
+                <a:solidFill>
+                  <a:srgbClr val="344054"/>
+                </a:solidFill>
+                <a:latin typeface="Aptos" pitchFamily="34" charset="0"/>
+                <a:ea typeface="Aptos" pitchFamily="34" charset="-122"/>
+                <a:cs typeface="Aptos" pitchFamily="34" charset="-120"/>
+              </a:rPr>
+              <a:t>predict scores for the task</a:t>
+            </a:r>
+            <a:endParaRPr lang="en-US" sz="1050" dirty="0"/>
+          </a:p>
+        </p:txBody>
+      </p:sp>
+      <p:sp>
+        <p:nvSpPr>
+          <p:cNvPr id="20" name="Shape 18"/>
+          <p:cNvSpPr/>
+          <p:nvPr/>
+        </p:nvSpPr>
+        <p:spPr>
+          <a:xfrm>
+            <a:off x="8759952" y="2075688"/>
+            <a:ext cx="393192" cy="0"/>
+          </a:xfrm>
+          <a:prstGeom prst="line">
+            <a:avLst/>
+          </a:prstGeom>
+          <a:noFill/>
+          <a:ln w="19050">
+            <a:solidFill>
+              <a:srgbClr val="003B95"/>
+            </a:solidFill>
+            <a:prstDash val="solid"/>
+            <a:tailEnd type="triangle"/>
+          </a:ln>
+        </p:spPr>
+      </p:sp>
+      <p:sp>
+        <p:nvSpPr>
+          <p:cNvPr id="21" name="Text 19"/>
+          <p:cNvSpPr/>
+          <p:nvPr/>
+        </p:nvSpPr>
+        <p:spPr>
+          <a:xfrm>
+            <a:off x="9290304" y="1773936"/>
+            <a:ext cx="2240280" cy="603504"/>
+          </a:xfrm>
+          <a:prstGeom prst="roundRect">
+            <a:avLst>
+              <a:gd name="adj" fmla="val 7576"/>
+            </a:avLst>
+          </a:prstGeom>
+          <a:solidFill>
+            <a:srgbClr val="FFF4C7"/>
+          </a:solidFill>
+          <a:ln w="10160">
+            <a:solidFill>
+              <a:srgbClr val="9A6A00"/>
+            </a:solidFill>
+          </a:ln>
+        </p:spPr>
+        <p:txBody>
+          <a:bodyPr wrap="square" lIns="1778" tIns="1778" rIns="1778" bIns="1778" rtlCol="0" anchor="ctr"/>
+          <a:lstStyle/>
+          <a:p>
+            <a:pPr algn="ctr" indent="0" marL="0">
+              <a:buNone/>
+            </a:pPr>
+            <a:r>
+              <a:rPr lang="en-US" sz="1250" b="1" dirty="0">
+                <a:solidFill>
+                  <a:srgbClr val="14213D"/>
+                </a:solidFill>
+                <a:latin typeface="Aptos" pitchFamily="34" charset="0"/>
+                <a:ea typeface="Aptos" pitchFamily="34" charset="-122"/>
+                <a:cs typeface="Aptos" pitchFamily="34" charset="-120"/>
+              </a:rPr>
+              <a:t>Evaluate finalists</a:t>
+            </a:r>
+            <a:endParaRPr lang="en-US" sz="1250" dirty="0"/>
+          </a:p>
+        </p:txBody>
+      </p:sp>
+      <p:sp>
+        <p:nvSpPr>
+          <p:cNvPr id="22" name="Text 20"/>
+          <p:cNvSpPr/>
+          <p:nvPr/>
+        </p:nvSpPr>
+        <p:spPr>
+          <a:xfrm>
+            <a:off x="9290304" y="2532888"/>
+            <a:ext cx="2240280" cy="420624"/>
+          </a:xfrm>
+          <a:prstGeom prst="rect">
+            <a:avLst/>
+          </a:prstGeom>
+          <a:noFill/>
+          <a:ln/>
+        </p:spPr>
+        <p:txBody>
+          <a:bodyPr wrap="square" lIns="0" tIns="0" rIns="0" bIns="0" rtlCol="0" anchor="t"/>
+          <a:lstStyle/>
+          <a:p>
+            <a:pPr algn="ctr" indent="0" marL="0">
+              <a:buNone/>
+            </a:pPr>
+            <a:r>
+              <a:rPr lang="en-US" sz="1050" dirty="0">
+                <a:solidFill>
+                  <a:srgbClr val="344054"/>
+                </a:solidFill>
+                <a:latin typeface="Aptos" pitchFamily="34" charset="0"/>
+                <a:ea typeface="Aptos" pitchFamily="34" charset="-122"/>
+                <a:cs typeface="Aptos" pitchFamily="34" charset="-120"/>
+              </a:rPr>
+              <a:t>spend the remaining budget</a:t>
+            </a:r>
+            <a:endParaRPr lang="en-US" sz="1050" dirty="0"/>
+          </a:p>
+        </p:txBody>
+      </p:sp>
+      <p:sp>
+        <p:nvSpPr>
+          <p:cNvPr id="23" name="Text 21"/>
+          <p:cNvSpPr/>
+          <p:nvPr/>
+        </p:nvSpPr>
+        <p:spPr>
+          <a:xfrm>
+            <a:off x="621792" y="3145536"/>
+            <a:ext cx="5212080" cy="219456"/>
+          </a:xfrm>
+          <a:prstGeom prst="rect">
+            <a:avLst/>
+          </a:prstGeom>
+          <a:noFill/>
+          <a:ln/>
+        </p:spPr>
+        <p:txBody>
+          <a:bodyPr wrap="square" lIns="0" tIns="0" rIns="0" bIns="0" rtlCol="0" anchor="t"/>
+          <a:lstStyle/>
+          <a:p>
+            <a:pPr indent="0" marL="0">
+              <a:buNone/>
+            </a:pPr>
+            <a:r>
+              <a:rPr lang="en-US" sz="1000" b="1" dirty="0">
+                <a:solidFill>
+                  <a:srgbClr val="003B95"/>
+                </a:solidFill>
+                <a:latin typeface="Aptos" pitchFamily="34" charset="0"/>
+                <a:ea typeface="Aptos" pitchFamily="34" charset="-122"/>
+                <a:cs typeface="Aptos" pitchFamily="34" charset="-120"/>
+              </a:rPr>
+              <a:t>COLLECTOR CAPABILITIES NOW</a:t>
+            </a:r>
+            <a:endParaRPr lang="en-US" sz="1000" dirty="0"/>
+          </a:p>
+        </p:txBody>
+      </p:sp>
+      <p:sp>
+        <p:nvSpPr>
+          <p:cNvPr id="24" name="Shape 22"/>
+          <p:cNvSpPr/>
+          <p:nvPr/>
+        </p:nvSpPr>
+        <p:spPr>
+          <a:xfrm>
+            <a:off x="621792" y="3493008"/>
+            <a:ext cx="5212080" cy="0"/>
+          </a:xfrm>
+          <a:prstGeom prst="line">
+            <a:avLst/>
+          </a:prstGeom>
+          <a:noFill/>
+          <a:ln w="20320">
+            <a:solidFill>
+              <a:srgbClr val="003B95"/>
+            </a:solidFill>
+            <a:prstDash val="solid"/>
+          </a:ln>
+        </p:spPr>
+      </p:sp>
+      <p:sp>
+        <p:nvSpPr>
+          <p:cNvPr id="25" name="Text 23"/>
+          <p:cNvSpPr/>
+          <p:nvPr/>
+        </p:nvSpPr>
+        <p:spPr>
+          <a:xfrm>
+            <a:off x="621792" y="3675888"/>
+            <a:ext cx="5212080" cy="749808"/>
+          </a:xfrm>
+          <a:prstGeom prst="rect">
+            <a:avLst/>
+          </a:prstGeom>
+          <a:noFill/>
+          <a:ln/>
+        </p:spPr>
+        <p:txBody>
+          <a:bodyPr wrap="square" lIns="0" tIns="0" rIns="0" bIns="0" rtlCol="0" anchor="t"/>
+          <a:lstStyle/>
+          <a:p>
+            <a:pPr indent="0" marL="0">
+              <a:buNone/>
+            </a:pPr>
+            <a:r>
+              <a:rPr lang="en-US" sz="1150" dirty="0">
+                <a:solidFill>
+                  <a:srgbClr val="344054"/>
+                </a:solidFill>
+                <a:latin typeface="Aptos" pitchFamily="34" charset="0"/>
+                <a:ea typeface="Aptos" pitchFamily="34" charset="-122"/>
+                <a:cs typeface="Aptos" pitchFamily="34" charset="-120"/>
+              </a:rPr>
+              <a:t>Pinned revisions, canonical matrix records, full computed spectra, and explicit coverage.</a:t>
+            </a:r>
+            <a:endParaRPr lang="en-US" sz="1150" dirty="0"/>
+          </a:p>
+          <a:p>
+            <a:pPr indent="0" marL="0">
+              <a:buNone/>
+            </a:pPr>
+            <a:r>
+              <a:rPr lang="en-US" sz="1150" dirty="0">
+                <a:solidFill>
+                  <a:srgbClr val="344054"/>
+                </a:solidFill>
+                <a:latin typeface="Aptos" pitchFamily="34" charset="0"/>
+                <a:ea typeface="Aptos" pitchFamily="34" charset="-122"/>
+                <a:cs typeface="Aptos" pitchFamily="34" charset="-120"/>
+              </a:rPr>
+              <a:t>New records still need verified benchmark joins and prediction experiments.</a:t>
+            </a:r>
+            <a:endParaRPr lang="en-US" sz="1150" dirty="0"/>
+          </a:p>
+        </p:txBody>
+      </p:sp>
+      <p:sp>
+        <p:nvSpPr>
+          <p:cNvPr id="26" name="Text 24"/>
+          <p:cNvSpPr/>
+          <p:nvPr/>
+        </p:nvSpPr>
+        <p:spPr>
+          <a:xfrm>
+            <a:off x="6419088" y="3145536"/>
+            <a:ext cx="5148072" cy="219456"/>
+          </a:xfrm>
+          <a:prstGeom prst="rect">
+            <a:avLst/>
+          </a:prstGeom>
+          <a:noFill/>
+          <a:ln/>
+        </p:spPr>
+        <p:txBody>
+          <a:bodyPr wrap="square" lIns="0" tIns="0" rIns="0" bIns="0" rtlCol="0" anchor="t"/>
+          <a:lstStyle/>
+          <a:p>
+            <a:pPr indent="0" marL="0">
+              <a:buNone/>
+            </a:pPr>
+            <a:r>
+              <a:rPr lang="en-US" sz="1000" b="1" dirty="0">
+                <a:solidFill>
+                  <a:srgbClr val="00693E"/>
+                </a:solidFill>
+                <a:latin typeface="Aptos" pitchFamily="34" charset="0"/>
+                <a:ea typeface="Aptos" pitchFamily="34" charset="-122"/>
+                <a:cs typeface="Aptos" pitchFamily="34" charset="-120"/>
+              </a:rPr>
+              <a:t>PROPOSED EVIDENCE COMPARISON</a:t>
+            </a:r>
+            <a:endParaRPr lang="en-US" sz="1000" dirty="0"/>
+          </a:p>
+        </p:txBody>
+      </p:sp>
+      <p:sp>
+        <p:nvSpPr>
+          <p:cNvPr id="27" name="Shape 25"/>
+          <p:cNvSpPr/>
+          <p:nvPr/>
+        </p:nvSpPr>
+        <p:spPr>
+          <a:xfrm>
+            <a:off x="6419088" y="3493008"/>
+            <a:ext cx="5148072" cy="0"/>
+          </a:xfrm>
+          <a:prstGeom prst="line">
+            <a:avLst/>
+          </a:prstGeom>
+          <a:noFill/>
+          <a:ln w="20320">
+            <a:solidFill>
+              <a:srgbClr val="00693E"/>
+            </a:solidFill>
+            <a:prstDash val="solid"/>
+          </a:ln>
+        </p:spPr>
+      </p:sp>
+      <p:sp>
+        <p:nvSpPr>
+          <p:cNvPr id="28" name="Text 26"/>
+          <p:cNvSpPr/>
+          <p:nvPr/>
+        </p:nvSpPr>
+        <p:spPr>
+          <a:xfrm>
+            <a:off x="6419088" y="3675888"/>
+            <a:ext cx="5148072" cy="749808"/>
+          </a:xfrm>
+          <a:prstGeom prst="rect">
+            <a:avLst/>
+          </a:prstGeom>
+          <a:noFill/>
+          <a:ln/>
+        </p:spPr>
+        <p:txBody>
+          <a:bodyPr wrap="square" lIns="0" tIns="0" rIns="0" bIns="0" rtlCol="0" anchor="t"/>
+          <a:lstStyle/>
+          <a:p>
+            <a:pPr indent="0" marL="0">
+              <a:buNone/>
+            </a:pPr>
+            <a:r>
+              <a:rPr lang="en-US" sz="1150" dirty="0">
+                <a:solidFill>
+                  <a:srgbClr val="344054"/>
+                </a:solidFill>
+                <a:latin typeface="Aptos" pitchFamily="34" charset="0"/>
+                <a:ea typeface="Aptos" pitchFamily="34" charset="-122"/>
+                <a:cs typeface="Aptos" pitchFamily="34" charset="-120"/>
+              </a:rPr>
+              <a:t>Scientific track: weights plus training scores.</a:t>
+            </a:r>
+            <a:endParaRPr lang="en-US" sz="1150" dirty="0"/>
+          </a:p>
+          <a:p>
+            <a:pPr indent="0" marL="0">
+              <a:buNone/>
+            </a:pPr>
+            <a:r>
+              <a:rPr lang="en-US" sz="1150" dirty="0">
+                <a:solidFill>
+                  <a:srgbClr val="344054"/>
+                </a:solidFill>
+                <a:latin typeface="Aptos" pitchFamily="34" charset="0"/>
+                <a:ea typeface="Aptos" pitchFamily="34" charset="-122"/>
+                <a:cs typeface="Aptos" pitchFamily="34" charset="-120"/>
+              </a:rPr>
+              <a:t>Practical track: documentation, historical scores, and weights.</a:t>
+            </a:r>
+            <a:endParaRPr lang="en-US" sz="1150" dirty="0"/>
+          </a:p>
+          <a:p>
+            <a:pPr indent="0" marL="0">
+              <a:buNone/>
+            </a:pPr>
+            <a:r>
+              <a:rPr lang="en-US" sz="1150" dirty="0">
+                <a:solidFill>
+                  <a:srgbClr val="344054"/>
+                </a:solidFill>
+                <a:latin typeface="Aptos" pitchFamily="34" charset="0"/>
+                <a:ea typeface="Aptos" pitchFamily="34" charset="-122"/>
+                <a:cs typeface="Aptos" pitchFamily="34" charset="-120"/>
+              </a:rPr>
+              <a:t>Test new roots, tasks, and future releases.</a:t>
+            </a:r>
+            <a:endParaRPr lang="en-US" sz="1150" dirty="0"/>
+          </a:p>
+        </p:txBody>
+      </p:sp>
+      <p:sp>
+        <p:nvSpPr>
+          <p:cNvPr id="29" name="Text 27"/>
+          <p:cNvSpPr/>
+          <p:nvPr/>
+        </p:nvSpPr>
+        <p:spPr>
+          <a:xfrm>
+            <a:off x="621792" y="4718304"/>
+            <a:ext cx="10954512" cy="219456"/>
+          </a:xfrm>
+          <a:prstGeom prst="rect">
+            <a:avLst/>
+          </a:prstGeom>
+          <a:noFill/>
+          <a:ln/>
+        </p:spPr>
+        <p:txBody>
+          <a:bodyPr wrap="square" lIns="0" tIns="0" rIns="0" bIns="0" rtlCol="0" anchor="t"/>
+          <a:lstStyle/>
+          <a:p>
+            <a:pPr indent="0" marL="0">
+              <a:buNone/>
+            </a:pPr>
+            <a:r>
+              <a:rPr lang="en-US" sz="1000" b="1" dirty="0">
+                <a:solidFill>
+                  <a:srgbClr val="667085"/>
+                </a:solidFill>
+                <a:latin typeface="Aptos" pitchFamily="34" charset="0"/>
+                <a:ea typeface="Aptos" pitchFamily="34" charset="-122"/>
+                <a:cs typeface="Aptos" pitchFamily="34" charset="-120"/>
+              </a:rPr>
+              <a:t>PROPOSED COLLECTION MILESTONES</a:t>
+            </a:r>
+            <a:endParaRPr lang="en-US" sz="1000" dirty="0"/>
+          </a:p>
+        </p:txBody>
+      </p:sp>
+      <p:sp>
+        <p:nvSpPr>
+          <p:cNvPr id="30" name="Shape 28"/>
+          <p:cNvSpPr/>
+          <p:nvPr/>
+        </p:nvSpPr>
+        <p:spPr>
+          <a:xfrm>
+            <a:off x="786384" y="5175504"/>
+            <a:ext cx="10579608" cy="0"/>
+          </a:xfrm>
+          <a:prstGeom prst="line">
+            <a:avLst/>
+          </a:prstGeom>
+          <a:noFill/>
+          <a:ln w="25400">
+            <a:solidFill>
+              <a:srgbClr val="D9E2EC"/>
+            </a:solidFill>
+            <a:prstDash val="solid"/>
+          </a:ln>
+        </p:spPr>
+      </p:sp>
+      <p:sp>
+        <p:nvSpPr>
+          <p:cNvPr id="31" name="Shape 29"/>
+          <p:cNvSpPr/>
+          <p:nvPr/>
+        </p:nvSpPr>
+        <p:spPr>
+          <a:xfrm>
+            <a:off x="731520" y="5120640"/>
+            <a:ext cx="109728" cy="109728"/>
+          </a:xfrm>
+          <a:prstGeom prst="ellipse">
+            <a:avLst/>
+          </a:prstGeom>
+          <a:solidFill>
+            <a:srgbClr val="003B95"/>
+          </a:solidFill>
+          <a:ln w="12700">
+            <a:solidFill>
+              <a:srgbClr val="333333">
+                <a:alpha val="0"/>
+              </a:srgbClr>
+            </a:solidFill>
+            <a:prstDash val="solid"/>
+          </a:ln>
+        </p:spPr>
+      </p:sp>
+      <p:sp>
+        <p:nvSpPr>
+          <p:cNvPr id="32" name="Text 30"/>
+          <p:cNvSpPr/>
+          <p:nvPr/>
+        </p:nvSpPr>
+        <p:spPr>
+          <a:xfrm>
+            <a:off x="621792" y="5449824"/>
+            <a:ext cx="3328416" cy="310896"/>
+          </a:xfrm>
+          <a:prstGeom prst="rect">
+            <a:avLst/>
+          </a:prstGeom>
+          <a:noFill/>
+          <a:ln/>
+        </p:spPr>
+        <p:txBody>
+          <a:bodyPr wrap="square" lIns="0" tIns="0" rIns="0" bIns="0" rtlCol="0" anchor="t"/>
+          <a:lstStyle/>
+          <a:p>
+            <a:pPr indent="0" marL="0">
+              <a:buNone/>
+            </a:pPr>
+            <a:r>
+              <a:rPr lang="en-US" sz="1600" b="1" dirty="0">
+                <a:solidFill>
+                  <a:srgbClr val="003B95"/>
+                </a:solidFill>
+                <a:latin typeface="Aptos" pitchFamily="34" charset="0"/>
+                <a:ea typeface="Aptos" pitchFamily="34" charset="-122"/>
+                <a:cs typeface="Aptos" pitchFamily="34" charset="-120"/>
+              </a:rPr>
+              <a:t>1k pinned artifacts</a:t>
+            </a:r>
+            <a:endParaRPr lang="en-US" sz="1600" dirty="0"/>
+          </a:p>
+        </p:txBody>
+      </p:sp>
+      <p:sp>
+        <p:nvSpPr>
+          <p:cNvPr id="33" name="Text 31"/>
+          <p:cNvSpPr/>
+          <p:nvPr/>
+        </p:nvSpPr>
+        <p:spPr>
+          <a:xfrm>
+            <a:off x="621792" y="5888736"/>
+            <a:ext cx="3328416" cy="347472"/>
+          </a:xfrm>
+          <a:prstGeom prst="rect">
+            <a:avLst/>
+          </a:prstGeom>
+          <a:noFill/>
+          <a:ln/>
+        </p:spPr>
+        <p:txBody>
+          <a:bodyPr wrap="square" lIns="0" tIns="0" rIns="0" bIns="0" rtlCol="0" anchor="t"/>
+          <a:lstStyle/>
+          <a:p>
+            <a:pPr indent="0" marL="0">
+              <a:buNone/>
+            </a:pPr>
+            <a:r>
+              <a:rPr lang="en-US" sz="1050" dirty="0">
+                <a:solidFill>
+                  <a:srgbClr val="344054"/>
+                </a:solidFill>
+                <a:latin typeface="Aptos" pitchFamily="34" charset="0"/>
+                <a:ea typeface="Aptos" pitchFamily="34" charset="-122"/>
+                <a:cs typeface="Aptos" pitchFamily="34" charset="-120"/>
+              </a:rPr>
+              <a:t>Measure collection cost and coverage</a:t>
+            </a:r>
+            <a:endParaRPr lang="en-US" sz="1050" dirty="0"/>
+          </a:p>
+        </p:txBody>
+      </p:sp>
+      <p:sp>
+        <p:nvSpPr>
+          <p:cNvPr id="34" name="Shape 32"/>
+          <p:cNvSpPr/>
+          <p:nvPr/>
+        </p:nvSpPr>
+        <p:spPr>
+          <a:xfrm>
+            <a:off x="4544568" y="5120640"/>
+            <a:ext cx="109728" cy="109728"/>
+          </a:xfrm>
+          <a:prstGeom prst="ellipse">
+            <a:avLst/>
+          </a:prstGeom>
+          <a:solidFill>
+            <a:srgbClr val="00693E"/>
+          </a:solidFill>
+          <a:ln w="12700">
+            <a:solidFill>
+              <a:srgbClr val="333333">
+                <a:alpha val="0"/>
+              </a:srgbClr>
+            </a:solidFill>
+            <a:prstDash val="solid"/>
+          </a:ln>
+        </p:spPr>
+      </p:sp>
+      <p:sp>
+        <p:nvSpPr>
+          <p:cNvPr id="35" name="Text 33"/>
+          <p:cNvSpPr/>
+          <p:nvPr/>
+        </p:nvSpPr>
+        <p:spPr>
+          <a:xfrm>
+            <a:off x="4434840" y="5449824"/>
+            <a:ext cx="3328416" cy="310896"/>
+          </a:xfrm>
+          <a:prstGeom prst="rect">
+            <a:avLst/>
+          </a:prstGeom>
+          <a:noFill/>
+          <a:ln/>
+        </p:spPr>
+        <p:txBody>
+          <a:bodyPr wrap="square" lIns="0" tIns="0" rIns="0" bIns="0" rtlCol="0" anchor="t"/>
+          <a:lstStyle/>
+          <a:p>
+            <a:pPr indent="0" marL="0">
+              <a:buNone/>
+            </a:pPr>
+            <a:r>
+              <a:rPr lang="en-US" sz="1600" b="1" dirty="0">
+                <a:solidFill>
+                  <a:srgbClr val="00693E"/>
+                </a:solidFill>
+                <a:latin typeface="Aptos" pitchFamily="34" charset="0"/>
+                <a:ea typeface="Aptos" pitchFamily="34" charset="-122"/>
+                <a:cs typeface="Aptos" pitchFamily="34" charset="-120"/>
+              </a:rPr>
+              <a:t>5k-10k measured</a:t>
+            </a:r>
+            <a:endParaRPr lang="en-US" sz="1600" dirty="0"/>
+          </a:p>
+        </p:txBody>
+      </p:sp>
+      <p:sp>
+        <p:nvSpPr>
+          <p:cNvPr id="36" name="Text 34"/>
+          <p:cNvSpPr/>
+          <p:nvPr/>
+        </p:nvSpPr>
+        <p:spPr>
+          <a:xfrm>
+            <a:off x="4434840" y="5888736"/>
+            <a:ext cx="3328416" cy="347472"/>
+          </a:xfrm>
+          <a:prstGeom prst="rect">
+            <a:avLst/>
+          </a:prstGeom>
+          <a:noFill/>
+          <a:ln/>
+        </p:spPr>
+        <p:txBody>
+          <a:bodyPr wrap="square" lIns="0" tIns="0" rIns="0" bIns="0" rtlCol="0" anchor="t"/>
+          <a:lstStyle/>
+          <a:p>
+            <a:pPr indent="0" marL="0">
+              <a:buNone/>
+            </a:pPr>
+            <a:r>
+              <a:rPr lang="en-US" sz="1050" dirty="0">
+                <a:solidFill>
+                  <a:srgbClr val="344054"/>
+                </a:solidFill>
+                <a:latin typeface="Aptos" pitchFamily="34" charset="0"/>
+                <a:ea typeface="Aptos" pitchFamily="34" charset="-122"/>
+                <a:cs typeface="Aptos" pitchFamily="34" charset="-120"/>
+              </a:rPr>
+              <a:t>Compare task choices and evidence</a:t>
+            </a:r>
+            <a:endParaRPr lang="en-US" sz="1050" dirty="0"/>
+          </a:p>
+        </p:txBody>
+      </p:sp>
+      <p:sp>
+        <p:nvSpPr>
+          <p:cNvPr id="37" name="Shape 35"/>
+          <p:cNvSpPr/>
+          <p:nvPr/>
+        </p:nvSpPr>
+        <p:spPr>
+          <a:xfrm>
+            <a:off x="8357616" y="5120640"/>
+            <a:ext cx="109728" cy="109728"/>
+          </a:xfrm>
+          <a:prstGeom prst="ellipse">
+            <a:avLst/>
+          </a:prstGeom>
+          <a:solidFill>
+            <a:srgbClr val="9A6A00"/>
+          </a:solidFill>
+          <a:ln w="12700">
+            <a:solidFill>
+              <a:srgbClr val="333333">
+                <a:alpha val="0"/>
+              </a:srgbClr>
+            </a:solidFill>
+            <a:prstDash val="solid"/>
+          </a:ln>
+        </p:spPr>
+      </p:sp>
+      <p:sp>
+        <p:nvSpPr>
+          <p:cNvPr id="38" name="Text 36"/>
+          <p:cNvSpPr/>
+          <p:nvPr/>
+        </p:nvSpPr>
+        <p:spPr>
+          <a:xfrm>
+            <a:off x="8247888" y="5449824"/>
+            <a:ext cx="3328416" cy="310896"/>
+          </a:xfrm>
+          <a:prstGeom prst="rect">
+            <a:avLst/>
+          </a:prstGeom>
+          <a:noFill/>
+          <a:ln/>
+        </p:spPr>
+        <p:txBody>
+          <a:bodyPr wrap="square" lIns="0" tIns="0" rIns="0" bIns="0" rtlCol="0" anchor="t"/>
+          <a:lstStyle/>
+          <a:p>
+            <a:pPr indent="0" marL="0">
+              <a:buNone/>
+            </a:pPr>
+            <a:r>
+              <a:rPr lang="en-US" sz="1600" b="1" dirty="0">
+                <a:solidFill>
+                  <a:srgbClr val="9A6A00"/>
+                </a:solidFill>
+                <a:latin typeface="Aptos" pitchFamily="34" charset="0"/>
+                <a:ea typeface="Aptos" pitchFamily="34" charset="-122"/>
+                <a:cs typeface="Aptos" pitchFamily="34" charset="-120"/>
+              </a:rPr>
+              <a:t>50k measured target</a:t>
+            </a:r>
+            <a:endParaRPr lang="en-US" sz="1600" dirty="0"/>
+          </a:p>
+        </p:txBody>
+      </p:sp>
+      <p:sp>
+        <p:nvSpPr>
+          <p:cNvPr id="39" name="Text 37"/>
+          <p:cNvSpPr/>
+          <p:nvPr/>
+        </p:nvSpPr>
+        <p:spPr>
+          <a:xfrm>
+            <a:off x="8247888" y="5888736"/>
+            <a:ext cx="3328416" cy="347472"/>
+          </a:xfrm>
+          <a:prstGeom prst="rect">
+            <a:avLst/>
+          </a:prstGeom>
+          <a:noFill/>
+          <a:ln/>
+        </p:spPr>
+        <p:txBody>
+          <a:bodyPr wrap="square" lIns="0" tIns="0" rIns="0" bIns="0" rtlCol="0" anchor="t"/>
+          <a:lstStyle/>
+          <a:p>
+            <a:pPr indent="0" marL="0">
+              <a:buNone/>
+            </a:pPr>
+            <a:r>
+              <a:rPr lang="en-US" sz="1050" dirty="0">
+                <a:solidFill>
+                  <a:srgbClr val="344054"/>
+                </a:solidFill>
+                <a:latin typeface="Aptos" pitchFamily="34" charset="0"/>
+                <a:ea typeface="Aptos" pitchFamily="34" charset="-122"/>
+                <a:cs typeface="Aptos" pitchFamily="34" charset="-120"/>
+              </a:rPr>
+              <a:t>Release the zoo and benchmark</a:t>
+            </a:r>
+            <a:endParaRPr lang="en-US" sz="1050" dirty="0"/>
+          </a:p>
+        </p:txBody>
+      </p:sp>
+    </p:spTree>
+  </p:cSld>
+  <p:clrMapOvr>
+    <a:masterClrMapping/>
+  </p:clrMapOvr>
+</p:sld>
+</file>
+
 <file path=ppt/slides/slide3.xml><?xml version="1.0" encoding="utf-8"?>
 <p:sld xmlns:a="http://schemas.openxmlformats.org/drawingml/2006/main" xmlns:r="http://schemas.openxmlformats.org/officeDocument/2006/relationships" xmlns:p="http://schemas.openxmlformats.org/presentationml/2006/main">
   <p:cSld name="Slide 3">
@@ -24445,7 +26074,7 @@
                 <a:ea typeface="Aptos Display" pitchFamily="34" charset="-122"/>
                 <a:cs typeface="Aptos Display" pitchFamily="34" charset="-120"/>
               </a:rPr>
-              <a:t>Role coverage and all-matrix coverage answer different questions</a:t>
+              <a:t>How much of the collection can layer-wise grouping cover?</a:t>
             </a:r>
             <a:endParaRPr lang="en-US" sz="2500" dirty="0"/>
           </a:p>
@@ -24530,7 +26159,7 @@
                 <a:ea typeface="Aptos" pitchFamily="34" charset="-122"/>
                 <a:cs typeface="Aptos" pitchFamily="34" charset="-120"/>
               </a:rPr>
-              <a:t>Sources: parent population_ledger.csv; reassessment_0063666fd5733b453c38/metadata.json and all_matrix_cluster_validation.csv</a:t>
+              <a:t>Sources: weight_only_2a5abfeb98dc33d9662c/population_ledger.csv; retained combined-study provenance.json</a:t>
             </a:r>
             <a:endParaRPr lang="en-US" sz="660" dirty="0"/>
           </a:p>
@@ -24591,8 +26220,8 @@
         </p:blipFill>
         <p:spPr>
           <a:xfrm>
-            <a:off x="475488" y="1999781"/>
-            <a:ext cx="7360920" cy="3343070"/>
+            <a:off x="384048" y="1866779"/>
+            <a:ext cx="7333488" cy="3709658"/>
           </a:xfrm>
           <a:prstGeom prst="rect">
             <a:avLst/>
@@ -24607,8 +26236,8 @@
         </p:nvSpPr>
         <p:spPr>
           <a:xfrm>
-            <a:off x="8156448" y="1252728"/>
-            <a:ext cx="2651760" cy="438912"/>
+            <a:off x="8092440" y="1298448"/>
+            <a:ext cx="2743200" cy="438912"/>
           </a:xfrm>
           <a:prstGeom prst="rect">
             <a:avLst/>
@@ -24626,13 +26255,13 @@
             <a:r>
               <a:rPr lang="en-US" sz="2700" b="1" dirty="0">
                 <a:solidFill>
-                  <a:srgbClr val="002676"/>
+                  <a:srgbClr val="003B95"/>
                 </a:solidFill>
                 <a:latin typeface="Aptos Display" pitchFamily="34" charset="0"/>
                 <a:ea typeface="Aptos Display" pitchFamily="34" charset="-122"/>
                 <a:cs typeface="Aptos Display" pitchFamily="34" charset="-120"/>
               </a:rPr>
-              <a:t>10,431</a:t>
+              <a:t>10,946</a:t>
             </a:r>
             <a:endParaRPr lang="en-US" sz="2700" dirty="0"/>
           </a:p>
@@ -24646,8 +26275,8 @@
         </p:nvSpPr>
         <p:spPr>
           <a:xfrm>
-            <a:off x="8156448" y="1737360"/>
-            <a:ext cx="2651760" cy="292608"/>
+            <a:off x="8092440" y="1783080"/>
+            <a:ext cx="2743200" cy="292608"/>
           </a:xfrm>
           <a:prstGeom prst="rect">
             <a:avLst/>
@@ -24671,7 +26300,7 @@
                 <a:ea typeface="Aptos" pitchFamily="34" charset="-122"/>
                 <a:cs typeface="Aptos" pitchFamily="34" charset="-120"/>
               </a:rPr>
-              <a:t>strict seven-role core</a:t>
+              <a:t>grouped models</a:t>
             </a:r>
             <a:endParaRPr lang="en-US" sz="1050" dirty="0"/>
           </a:p>
@@ -24685,8 +26314,8 @@
         </p:nvSpPr>
         <p:spPr>
           <a:xfrm>
-            <a:off x="8156448" y="2395728"/>
-            <a:ext cx="2651760" cy="438912"/>
+            <a:off x="8092440" y="2450592"/>
+            <a:ext cx="2743200" cy="438912"/>
           </a:xfrm>
           <a:prstGeom prst="rect">
             <a:avLst/>
@@ -24704,13 +26333,13 @@
             <a:r>
               <a:rPr lang="en-US" sz="2700" b="1" dirty="0">
                 <a:solidFill>
-                  <a:srgbClr val="003B95"/>
+                  <a:srgbClr val="00693E"/>
                 </a:solidFill>
                 <a:latin typeface="Aptos Display" pitchFamily="34" charset="0"/>
                 <a:ea typeface="Aptos Display" pitchFamily="34" charset="-122"/>
                 <a:cs typeface="Aptos Display" pitchFamily="34" charset="-120"/>
               </a:rPr>
-              <a:t>10,946</a:t>
+              <a:t>87.2%</a:t>
             </a:r>
             <a:endParaRPr lang="en-US" sz="2700" dirty="0"/>
           </a:p>
@@ -24724,8 +26353,8 @@
         </p:nvSpPr>
         <p:spPr>
           <a:xfrm>
-            <a:off x="8156448" y="2880360"/>
-            <a:ext cx="2651760" cy="292608"/>
+            <a:off x="8092440" y="2935224"/>
+            <a:ext cx="2743200" cy="292608"/>
           </a:xfrm>
           <a:prstGeom prst="rect">
             <a:avLst/>
@@ -24749,7 +26378,7 @@
                 <a:ea typeface="Aptos" pitchFamily="34" charset="-122"/>
                 <a:cs typeface="Aptos" pitchFamily="34" charset="-120"/>
               </a:rPr>
-              <a:t>lineage assignments</a:t>
+              <a:t>of analyzed models</a:t>
             </a:r>
             <a:endParaRPr lang="en-US" sz="1050" dirty="0"/>
           </a:p>
@@ -24763,8 +26392,8 @@
         </p:nvSpPr>
         <p:spPr>
           <a:xfrm>
-            <a:off x="8156448" y="3538728"/>
-            <a:ext cx="2468880" cy="438912"/>
+            <a:off x="8092440" y="3273552"/>
+            <a:ext cx="2743200" cy="365760"/>
           </a:xfrm>
           <a:prstGeom prst="rect">
             <a:avLst/>
@@ -24780,15 +26409,54 @@
               <a:buNone/>
             </a:pPr>
             <a:r>
+              <a:rPr lang="en-US" sz="840" dirty="0">
+                <a:solidFill>
+                  <a:srgbClr val="667085"/>
+                </a:solidFill>
+                <a:latin typeface="Aptos" pitchFamily="34" charset="0"/>
+                <a:ea typeface="Aptos" pitchFamily="34" charset="-122"/>
+                <a:cs typeface="Aptos" pitchFamily="34" charset="-120"/>
+              </a:rPr>
+              <a:t>10,946 / 12,553</a:t>
+            </a:r>
+            <a:endParaRPr lang="en-US" sz="840" dirty="0"/>
+          </a:p>
+        </p:txBody>
+      </p:sp>
+      <p:sp>
+        <p:nvSpPr>
+          <p:cNvPr id="17" name="Text 14"/>
+          <p:cNvSpPr/>
+          <p:nvPr/>
+        </p:nvSpPr>
+        <p:spPr>
+          <a:xfrm>
+            <a:off x="8092440" y="3648456"/>
+            <a:ext cx="2743200" cy="438912"/>
+          </a:xfrm>
+          <a:prstGeom prst="rect">
+            <a:avLst/>
+          </a:prstGeom>
+          <a:noFill/>
+          <a:ln/>
+        </p:spPr>
+        <p:txBody>
+          <a:bodyPr wrap="square" lIns="0" tIns="0" rIns="0" bIns="0" rtlCol="0" anchor="t"/>
+          <a:lstStyle/>
+          <a:p>
+            <a:pPr indent="0" marL="0">
+              <a:buNone/>
+            </a:pPr>
+            <a:r>
               <a:rPr lang="en-US" sz="2700" b="1" dirty="0">
                 <a:solidFill>
-                  <a:srgbClr val="00693E"/>
+                  <a:srgbClr val="002676"/>
                 </a:solidFill>
                 <a:latin typeface="Aptos Display" pitchFamily="34" charset="0"/>
                 <a:ea typeface="Aptos Display" pitchFamily="34" charset="-122"/>
                 <a:cs typeface="Aptos Display" pitchFamily="34" charset="-120"/>
               </a:rPr>
-              <a:t>12,365</a:t>
+              <a:t>55.5%</a:t>
             </a:r>
             <a:endParaRPr lang="en-US" sz="2700" dirty="0"/>
           </a:p>
@@ -24796,14 +26464,14 @@
       </p:sp>
       <p:sp>
         <p:nvSpPr>
-          <p:cNvPr id="17" name="Text 14"/>
-          <p:cNvSpPr/>
-          <p:nvPr/>
-        </p:nvSpPr>
-        <p:spPr>
-          <a:xfrm>
-            <a:off x="8156448" y="4023360"/>
-            <a:ext cx="2468880" cy="292608"/>
+          <p:cNvPr id="18" name="Text 15"/>
+          <p:cNvSpPr/>
+          <p:nvPr/>
+        </p:nvSpPr>
+        <p:spPr>
+          <a:xfrm>
+            <a:off x="8092440" y="4133088"/>
+            <a:ext cx="2743200" cy="292608"/>
           </a:xfrm>
           <a:prstGeom prst="rect">
             <a:avLst/>
@@ -24827,7 +26495,7 @@
                 <a:ea typeface="Aptos" pitchFamily="34" charset="-122"/>
                 <a:cs typeface="Aptos" pitchFamily="34" charset="-120"/>
               </a:rPr>
-              <a:t>all-matrix alpha eligible</a:t>
+              <a:t>of selected records</a:t>
             </a:r>
             <a:endParaRPr lang="en-US" sz="1050" dirty="0"/>
           </a:p>
@@ -24835,18 +26503,57 @@
       </p:sp>
       <p:sp>
         <p:nvSpPr>
-          <p:cNvPr id="18" name="Text 15"/>
-          <p:cNvSpPr/>
-          <p:nvPr/>
-        </p:nvSpPr>
-        <p:spPr>
-          <a:xfrm>
-            <a:off x="8065008" y="4828032"/>
-            <a:ext cx="3154680" cy="941832"/>
+          <p:cNvPr id="19" name="Text 16"/>
+          <p:cNvSpPr/>
+          <p:nvPr/>
+        </p:nvSpPr>
+        <p:spPr>
+          <a:xfrm>
+            <a:off x="8092440" y="4471416"/>
+            <a:ext cx="2743200" cy="365760"/>
+          </a:xfrm>
+          <a:prstGeom prst="rect">
+            <a:avLst/>
+          </a:prstGeom>
+          <a:noFill/>
+          <a:ln/>
+        </p:spPr>
+        <p:txBody>
+          <a:bodyPr wrap="square" lIns="0" tIns="0" rIns="0" bIns="0" rtlCol="0" anchor="t"/>
+          <a:lstStyle/>
+          <a:p>
+            <a:pPr indent="0" marL="0">
+              <a:buNone/>
+            </a:pPr>
+            <a:r>
+              <a:rPr lang="en-US" sz="840" dirty="0">
+                <a:solidFill>
+                  <a:srgbClr val="667085"/>
+                </a:solidFill>
+                <a:latin typeface="Aptos" pitchFamily="34" charset="0"/>
+                <a:ea typeface="Aptos" pitchFamily="34" charset="-122"/>
+                <a:cs typeface="Aptos" pitchFamily="34" charset="-120"/>
+              </a:rPr>
+              <a:t>10,946 / 19,713</a:t>
+            </a:r>
+            <a:endParaRPr lang="en-US" sz="840" dirty="0"/>
+          </a:p>
+        </p:txBody>
+      </p:sp>
+      <p:sp>
+        <p:nvSpPr>
+          <p:cNvPr id="20" name="Text 17"/>
+          <p:cNvSpPr/>
+          <p:nvPr/>
+        </p:nvSpPr>
+        <p:spPr>
+          <a:xfrm>
+            <a:off x="8065008" y="4992624"/>
+            <a:ext cx="3246120" cy="1051560"/>
           </a:xfrm>
           <a:prstGeom prst="roundRect">
             <a:avLst>
-              <a:gd name="adj" fmla="val 4854"/>
+              <a:gd name="adj" fmla="val 4348"/>
             </a:avLst>
           </a:prstGeom>
           <a:solidFill>
@@ -24874,7 +26581,7 @@
                 <a:ea typeface="Aptos" pitchFamily="34" charset="-122"/>
                 <a:cs typeface="Aptos" pitchFamily="34" charset="-120"/>
               </a:rPr>
-              <a:t>Broader eligibility does not imply better grouping. All-matrix family ARI 0.258 vs rank 0.913 on human-reviewed labels; populations differ.</a:t>
+              <a:t>Fixed seven-role vocabulary; only tested missing-role patterns are admitted. 7,160 selected records have no completed analysis. Unseen-architecture accuracy remains untested.</a:t>
             </a:r>
             <a:endParaRPr lang="en-US" sz="1050" dirty="0"/>
           </a:p>

</xml_diff>